<commit_message>
Final codebase cleanup: remove dead code and update documentation
</commit_message>
<xml_diff>
--- a/presentation/Financial_QA_Presentation.pptx
+++ b/presentation/Financial_QA_Presentation.pptx
@@ -4378,7 +4378,7 @@
                 </a:solidFill>
                 <a:latin typeface="Calibri"/>
               </a:rPr>
-              <a:t>Final Report (PDF, 19 pages, LaTeX)   •   Working Web App   •   Source Code   •   This Video</a:t>
+              <a:t>Final Report (body under 20-page limit)   •   Working Web App   •   Source Code   •   This Video</a:t>
             </a:r>
           </a:p>
         </p:txBody>
@@ -11144,7 +11144,7 @@
                             <a:srgbClr val="1F1F1F"/>
                           </a:solidFill>
                         </a:rPr>
-                        <a:t>0.333</a:t>
+                        <a:t>0.620</a:t>
                       </a:r>
                     </a:p>
                   </a:txBody>
@@ -11166,7 +11166,7 @@
                             <a:srgbClr val="1F1F1F"/>
                           </a:solidFill>
                         </a:rPr>
-                        <a:t>0.800</a:t>
+                        <a:t>0.963</a:t>
                       </a:r>
                     </a:p>
                   </a:txBody>
@@ -11188,7 +11188,7 @@
                             <a:srgbClr val="1F1F1F"/>
                           </a:solidFill>
                         </a:rPr>
-                        <a:t>4.9 ms</a:t>
+                        <a:t>10.09 ms</a:t>
                       </a:r>
                     </a:p>
                   </a:txBody>
@@ -11234,7 +11234,7 @@
                             <a:srgbClr val="1F1F1F"/>
                           </a:solidFill>
                         </a:rPr>
-                        <a:t>0.200</a:t>
+                        <a:t>0.447</a:t>
                       </a:r>
                     </a:p>
                   </a:txBody>
@@ -11256,7 +11256,7 @@
                             <a:srgbClr val="1F1F1F"/>
                           </a:solidFill>
                         </a:rPr>
-                        <a:t>0.517</a:t>
+                        <a:t>0.717</a:t>
                       </a:r>
                     </a:p>
                   </a:txBody>
@@ -11278,7 +11278,7 @@
                             <a:srgbClr val="1F1F1F"/>
                           </a:solidFill>
                         </a:rPr>
-                        <a:t>2.0 ms</a:t>
+                        <a:t>5.57 ms</a:t>
                       </a:r>
                     </a:p>
                   </a:txBody>
@@ -11324,7 +11324,7 @@
                             <a:srgbClr val="2E7D32"/>
                           </a:solidFill>
                         </a:rPr>
-                        <a:t>0.400</a:t>
+                        <a:t>0.580</a:t>
                       </a:r>
                     </a:p>
                   </a:txBody>
@@ -11368,7 +11368,7 @@
                             <a:srgbClr val="2E7D32"/>
                           </a:solidFill>
                         </a:rPr>
-                        <a:t>89.0 ms</a:t>
+                        <a:t>177.19 ms</a:t>
                       </a:r>
                     </a:p>
                   </a:txBody>
@@ -11881,7 +11881,7 @@
                 </a:solidFill>
                 <a:latin typeface="Calibri"/>
               </a:rPr>
-              <a:t>Same 5 financial questions, three answer strategies. Which approach hallucinates?</a:t>
+              <a:t>50 financial-qa-10K questions, three answer strategies. Which approach stays grounded?</a:t>
             </a:r>
           </a:p>
         </p:txBody>
@@ -12110,7 +12110,7 @@
                 </a:solidFill>
                 <a:latin typeface="Calibri"/>
               </a:rPr>
-              <a:t>0.400</a:t>
+              <a:t>0.008</a:t>
             </a:r>
           </a:p>
         </p:txBody>
@@ -12180,7 +12180,7 @@
                 </a:solidFill>
                 <a:latin typeface="Calibri"/>
               </a:rPr>
-              <a:t>0.600</a:t>
+              <a:t>1.000</a:t>
             </a:r>
           </a:p>
         </p:txBody>
@@ -12250,7 +12250,7 @@
                 </a:solidFill>
                 <a:latin typeface="Calibri"/>
               </a:rPr>
-              <a:t>1 / 5</a:t>
+              <a:t>0 / 50</a:t>
             </a:r>
           </a:p>
         </p:txBody>
@@ -12479,7 +12479,7 @@
                 </a:solidFill>
                 <a:latin typeface="Calibri"/>
               </a:rPr>
-              <a:t>0.200</a:t>
+              <a:t>0.133</a:t>
             </a:r>
           </a:p>
         </p:txBody>
@@ -12619,7 +12619,7 @@
                 </a:solidFill>
                 <a:latin typeface="Calibri"/>
               </a:rPr>
-              <a:t>0 / 5</a:t>
+              <a:t>0 / 50</a:t>
             </a:r>
           </a:p>
         </p:txBody>
@@ -12848,7 +12848,7 @@
                 </a:solidFill>
                 <a:latin typeface="Calibri"/>
               </a:rPr>
-              <a:t>1.000</a:t>
+              <a:t>0.840</a:t>
             </a:r>
           </a:p>
         </p:txBody>
@@ -12988,7 +12988,7 @@
                 </a:solidFill>
                 <a:latin typeface="Calibri"/>
               </a:rPr>
-              <a:t>0 / 5</a:t>
+              <a:t>0 / 50</a:t>
             </a:r>
           </a:p>
         </p:txBody>

</xml_diff>